<commit_message>
Atualizar apresentação do Sprint 1: CI no GitHub e slide de Scrum
</commit_message>
<xml_diff>
--- a/docs/apresentacao-sprint-1.pptx
+++ b/docs/apresentacao-sprint-1.pptx
@@ -10,6 +10,7 @@
     <p:sldId id="258" r:id="rId9"/>
     <p:sldId id="259" r:id="rId10"/>
     <p:sldId id="260" r:id="rId11"/>
+    <p:sldId id="262" r:id="rId13"/>
     <p:sldId id="261" r:id="rId12"/>
   </p:sldIdLst>
   <p:sldSz cx="12191695" cy="6858000" type="screen4x3"/>
@@ -4324,7 +4325,7 @@
               </a:defRPr>
             </a:pPr>
             <a:r>
-              <a:t>02 / 06</a:t>
+              <a:t>02 / 07</a:t>
             </a:r>
           </a:p>
         </p:txBody>
@@ -5362,7 +5363,7 @@
               </a:defRPr>
             </a:pPr>
             <a:r>
-              <a:t>03 / 06</a:t>
+              <a:t>03 / 07</a:t>
             </a:r>
           </a:p>
         </p:txBody>
@@ -7410,7 +7411,7 @@
               </a:defRPr>
             </a:pPr>
             <a:r>
-              <a:t>04 / 06</a:t>
+              <a:t>04 / 07</a:t>
             </a:r>
           </a:p>
         </p:txBody>
@@ -8171,7 +8172,7 @@
               </a:defRPr>
             </a:pPr>
             <a:r>
-              <a:t>a passar localmente</a:t>
+              <a:t>a passar no CI do GitHub</a:t>
             </a:r>
           </a:p>
         </p:txBody>
@@ -8567,7 +8568,7 @@
               </a:defRPr>
             </a:pPr>
             <a:r>
-              <a:t>05 / 06</a:t>
+              <a:t>05 / 07</a:t>
             </a:r>
           </a:p>
         </p:txBody>
@@ -9364,7 +9365,7 @@
               </a:defRPr>
             </a:pPr>
             <a:r>
-              <a:t>Protótipo local · regras testadas · CI configurada</a:t>
+              <a:t>Protótipo local · regras testadas · CI no GitHub</a:t>
             </a:r>
           </a:p>
         </p:txBody>
@@ -9519,7 +9520,7 @@
               </a:defRPr>
             </a:pPr>
             <a:r>
-              <a:t>CI remota pendente de publicação no GitHub. Copilot Chat apoiou o desenvolvimento; ainda não há gate de IA.</a:t>
+              <a:t>CI a correr no GitHub em cada push. Copilot Chat apoiou o desenvolvimento; ainda não há gate de IA.</a:t>
             </a:r>
             <a:br/>
             <a:r>
@@ -9585,7 +9586,7 @@
               </a:defRPr>
             </a:pPr>
             <a:r>
-              <a:t>06  /  DEMONSTRAÇÃO</a:t>
+              <a:t>07  /  DEMONSTRAÇÃO</a:t>
             </a:r>
           </a:p>
         </p:txBody>
@@ -10537,6 +10538,1163 @@
             </a:pPr>
             <a:r>
               <a:t>ReservaStudy · protótipo inicial de Sprint 1</a:t>
+            </a:r>
+          </a:p>
+        </p:txBody>
+      </p:sp>
+    </p:spTree>
+  </p:cSld>
+  <p:clrMapOvr>
+    <a:masterClrMapping/>
+  </p:clrMapOvr>
+</p:sld>
+</file>
+
+<file path=ppt/slides/slide7.xml><?xml version="1.0" encoding="utf-8"?>
+<p:sld xmlns:a="http://schemas.openxmlformats.org/drawingml/2006/main" xmlns:p="http://schemas.openxmlformats.org/presentationml/2006/main" xmlns:r="http://schemas.openxmlformats.org/officeDocument/2006/relationships">
+  <p:cSld>
+    <p:bg>
+      <p:bgPr>
+        <a:solidFill>
+          <a:srgbClr val="F8F7F2"/>
+        </a:solidFill>
+        <a:effectLst/>
+      </p:bgPr>
+    </p:bg>
+    <p:spTree>
+      <p:nvGrpSpPr>
+        <p:cNvPr id="1" name=""/>
+        <p:cNvGrpSpPr/>
+        <p:nvPr/>
+      </p:nvGrpSpPr>
+      <p:grpSpPr/>
+      <p:sp>
+        <p:nvSpPr>
+          <p:cNvPr id="2" name="TextBox 1"/>
+          <p:cNvSpPr txBox="1"/>
+          <p:nvPr/>
+        </p:nvSpPr>
+        <p:spPr>
+          <a:xfrm>
+            <a:off x="621792" y="256032"/>
+            <a:ext cx="2926080" cy="256032"/>
+          </a:xfrm>
+          <a:prstGeom prst="rect">
+            <a:avLst/>
+          </a:prstGeom>
+          <a:noFill/>
+        </p:spPr>
+        <p:txBody>
+          <a:bodyPr wrap="square" anchor="ctr" lIns="18288" rIns="18288" tIns="18288" bIns="18288">
+            <a:spAutoFit/>
+          </a:bodyPr>
+          <a:lstStyle/>
+          <a:p>
+            <a:pPr algn="l">
+              <a:defRPr sz="1000" b="1" i="0">
+                <a:solidFill>
+                  <a:srgbClr val="254638"/>
+                </a:solidFill>
+                <a:latin typeface="Aptos"/>
+              </a:defRPr>
+            </a:pPr>
+            <a:r>
+              <a:t>RESERVASTUDY</a:t>
+            </a:r>
+          </a:p>
+        </p:txBody>
+      </p:sp>
+      <p:sp>
+        <p:nvSpPr>
+          <p:cNvPr id="3" name="TextBox 2"/>
+          <p:cNvSpPr txBox="1"/>
+          <p:nvPr/>
+        </p:nvSpPr>
+        <p:spPr>
+          <a:xfrm>
+            <a:off x="8823960" y="256032"/>
+            <a:ext cx="2743200" cy="256032"/>
+          </a:xfrm>
+          <a:prstGeom prst="rect">
+            <a:avLst/>
+          </a:prstGeom>
+          <a:noFill/>
+        </p:spPr>
+        <p:txBody>
+          <a:bodyPr wrap="square" anchor="ctr" lIns="18288" rIns="18288" tIns="18288" bIns="18288">
+            <a:spAutoFit/>
+          </a:bodyPr>
+          <a:lstStyle/>
+          <a:p>
+            <a:pPr algn="r">
+              <a:defRPr sz="900" b="1" i="0">
+                <a:solidFill>
+                  <a:srgbClr val="6D746E"/>
+                </a:solidFill>
+                <a:latin typeface="Aptos"/>
+              </a:defRPr>
+            </a:pPr>
+            <a:r>
+              <a:t>SCRUM &amp; EQUIPA</a:t>
+            </a:r>
+          </a:p>
+        </p:txBody>
+      </p:sp>
+      <p:sp>
+        <p:nvSpPr>
+          <p:cNvPr id="4" name="TextBox 3"/>
+          <p:cNvSpPr txBox="1"/>
+          <p:nvPr/>
+        </p:nvSpPr>
+        <p:spPr>
+          <a:xfrm>
+            <a:off x="621792" y="713232"/>
+            <a:ext cx="10927080" cy="603504"/>
+          </a:xfrm>
+          <a:prstGeom prst="rect">
+            <a:avLst/>
+          </a:prstGeom>
+          <a:noFill/>
+        </p:spPr>
+        <p:txBody>
+          <a:bodyPr wrap="square" anchor="ctr" lIns="18288" rIns="18288" tIns="18288" bIns="18288">
+            <a:spAutoFit/>
+          </a:bodyPr>
+          <a:lstStyle/>
+          <a:p>
+            <a:pPr algn="l">
+              <a:defRPr sz="3000" b="1" i="0">
+                <a:solidFill>
+                  <a:srgbClr val="242925"/>
+                </a:solidFill>
+                <a:latin typeface="Aptos"/>
+              </a:defRPr>
+            </a:pPr>
+            <a:r>
+              <a:t>Como nos organizámos</a:t>
+            </a:r>
+          </a:p>
+        </p:txBody>
+      </p:sp>
+      <p:sp>
+        <p:nvSpPr>
+          <p:cNvPr id="5" name="TextBox 4"/>
+          <p:cNvSpPr txBox="1"/>
+          <p:nvPr/>
+        </p:nvSpPr>
+        <p:spPr>
+          <a:xfrm>
+            <a:off x="658368" y="1335024"/>
+            <a:ext cx="10881360" cy="384048"/>
+          </a:xfrm>
+          <a:prstGeom prst="rect">
+            <a:avLst/>
+          </a:prstGeom>
+          <a:noFill/>
+        </p:spPr>
+        <p:txBody>
+          <a:bodyPr wrap="square" anchor="ctr" lIns="18288" rIns="18288" tIns="18288" bIns="18288">
+            <a:spAutoFit/>
+          </a:bodyPr>
+          <a:lstStyle/>
+          <a:p>
+            <a:pPr algn="l">
+              <a:defRPr sz="1400" b="0" i="0">
+                <a:solidFill>
+                  <a:srgbClr val="6D746E"/>
+                </a:solidFill>
+                <a:latin typeface="Aptos"/>
+              </a:defRPr>
+            </a:pPr>
+            <a:r>
+              <a:t>Papéis, acordos e evidências registadas no Jira.</a:t>
+            </a:r>
+          </a:p>
+        </p:txBody>
+      </p:sp>
+      <p:cxnSp>
+        <p:nvCxnSpPr>
+          <p:cNvPr id="6" name="Connector 5"/>
+          <p:cNvCxnSpPr/>
+          <p:nvPr/>
+        </p:nvCxnSpPr>
+        <p:spPr>
+          <a:xfrm>
+            <a:off x="640080" y="6391656"/>
+            <a:ext cx="10908792" cy="0"/>
+          </a:xfrm>
+          <a:prstGeom prst="line">
+            <a:avLst/>
+          </a:prstGeom>
+          <a:ln w="10160">
+            <a:solidFill>
+              <a:srgbClr val="DCDED8"/>
+            </a:solidFill>
+          </a:ln>
+        </p:spPr>
+        <p:style>
+          <a:lnRef idx="2">
+            <a:schemeClr val="accent1"/>
+          </a:lnRef>
+          <a:fillRef idx="0">
+            <a:schemeClr val="accent1"/>
+          </a:fillRef>
+          <a:effectRef idx="1">
+            <a:schemeClr val="accent1"/>
+          </a:effectRef>
+          <a:fontRef idx="minor">
+            <a:schemeClr val="tx1"/>
+          </a:fontRef>
+        </p:style>
+      </p:cxnSp>
+      <p:sp>
+        <p:nvSpPr>
+          <p:cNvPr id="7" name="TextBox 6"/>
+          <p:cNvSpPr txBox="1"/>
+          <p:nvPr/>
+        </p:nvSpPr>
+        <p:spPr>
+          <a:xfrm>
+            <a:off x="658368" y="6473952"/>
+            <a:ext cx="7772400" cy="182880"/>
+          </a:xfrm>
+          <a:prstGeom prst="rect">
+            <a:avLst/>
+          </a:prstGeom>
+          <a:noFill/>
+        </p:spPr>
+        <p:txBody>
+          <a:bodyPr wrap="square" anchor="ctr" lIns="18288" rIns="18288" tIns="18288" bIns="18288">
+            <a:spAutoFit/>
+          </a:bodyPr>
+          <a:lstStyle/>
+          <a:p>
+            <a:pPr algn="l">
+              <a:defRPr sz="800" b="0" i="0">
+                <a:solidFill>
+                  <a:srgbClr val="6D746E"/>
+                </a:solidFill>
+                <a:latin typeface="Aptos"/>
+              </a:defRPr>
+            </a:pPr>
+            <a:r>
+              <a:t>José Baptista  ·  Rafael Vicente  |  X-Ops 2026/27</a:t>
+            </a:r>
+          </a:p>
+        </p:txBody>
+      </p:sp>
+      <p:sp>
+        <p:nvSpPr>
+          <p:cNvPr id="8" name="TextBox 7"/>
+          <p:cNvSpPr txBox="1"/>
+          <p:nvPr/>
+        </p:nvSpPr>
+        <p:spPr>
+          <a:xfrm>
+            <a:off x="10789920" y="6455664"/>
+            <a:ext cx="731520" cy="201168"/>
+          </a:xfrm>
+          <a:prstGeom prst="rect">
+            <a:avLst/>
+          </a:prstGeom>
+          <a:noFill/>
+        </p:spPr>
+        <p:txBody>
+          <a:bodyPr wrap="square" anchor="ctr" lIns="18288" rIns="18288" tIns="18288" bIns="18288">
+            <a:spAutoFit/>
+          </a:bodyPr>
+          <a:lstStyle/>
+          <a:p>
+            <a:pPr algn="r">
+              <a:defRPr sz="800" b="0" i="0">
+                <a:solidFill>
+                  <a:srgbClr val="6D746E"/>
+                </a:solidFill>
+                <a:latin typeface="Aptos"/>
+              </a:defRPr>
+            </a:pPr>
+            <a:r>
+              <a:t>06 / 07</a:t>
+            </a:r>
+          </a:p>
+        </p:txBody>
+      </p:sp>
+      <p:sp>
+        <p:nvSpPr>
+          <p:cNvPr id="9" name="Rounded Rectangle 8"/>
+          <p:cNvSpPr/>
+          <p:nvPr/>
+        </p:nvSpPr>
+        <p:spPr>
+          <a:xfrm>
+            <a:off x="731520" y="2084831"/>
+            <a:ext cx="6766560" cy="777240"/>
+          </a:xfrm>
+          <a:prstGeom prst="roundRect">
+            <a:avLst>
+              <a:gd name="adj" fmla="val 12000"/>
+            </a:avLst>
+          </a:prstGeom>
+          <a:solidFill>
+            <a:srgbClr val="FFFFFF"/>
+          </a:solidFill>
+          <a:ln w="10160">
+            <a:solidFill>
+              <a:srgbClr val="DCDED8"/>
+            </a:solidFill>
+          </a:ln>
+        </p:spPr>
+        <p:style>
+          <a:lnRef idx="1">
+            <a:schemeClr val="accent1"/>
+          </a:lnRef>
+          <a:fillRef idx="3">
+            <a:schemeClr val="accent1"/>
+          </a:fillRef>
+          <a:effectRef idx="2">
+            <a:schemeClr val="accent1"/>
+          </a:effectRef>
+          <a:fontRef idx="minor">
+            <a:schemeClr val="lt1"/>
+          </a:fontRef>
+        </p:style>
+        <p:txBody>
+          <a:bodyPr rtlCol="0" anchor="ctr"/>
+          <a:lstStyle/>
+          <a:p>
+            <a:pPr algn="ctr"/>
+          </a:p>
+        </p:txBody>
+      </p:sp>
+      <p:sp>
+        <p:nvSpPr>
+          <p:cNvPr id="10" name="Rounded Rectangle 9"/>
+          <p:cNvSpPr/>
+          <p:nvPr/>
+        </p:nvSpPr>
+        <p:spPr>
+          <a:xfrm>
+            <a:off x="932688" y="2249424"/>
+            <a:ext cx="393192" cy="393192"/>
+          </a:xfrm>
+          <a:prstGeom prst="roundRect">
+            <a:avLst>
+              <a:gd name="adj" fmla="val 12000"/>
+            </a:avLst>
+          </a:prstGeom>
+          <a:solidFill>
+            <a:srgbClr val="DCE7DC"/>
+          </a:solidFill>
+          <a:ln w="10160">
+            <a:solidFill>
+              <a:srgbClr val="DCE7DC"/>
+            </a:solidFill>
+          </a:ln>
+        </p:spPr>
+        <p:style>
+          <a:lnRef idx="1">
+            <a:schemeClr val="accent1"/>
+          </a:lnRef>
+          <a:fillRef idx="3">
+            <a:schemeClr val="accent1"/>
+          </a:fillRef>
+          <a:effectRef idx="2">
+            <a:schemeClr val="accent1"/>
+          </a:effectRef>
+          <a:fontRef idx="minor">
+            <a:schemeClr val="lt1"/>
+          </a:fontRef>
+        </p:style>
+        <p:txBody>
+          <a:bodyPr rtlCol="0" anchor="ctr"/>
+          <a:lstStyle/>
+          <a:p>
+            <a:pPr algn="ctr"/>
+          </a:p>
+        </p:txBody>
+      </p:sp>
+      <p:sp>
+        <p:nvSpPr>
+          <p:cNvPr id="11" name="TextBox 10"/>
+          <p:cNvSpPr txBox="1"/>
+          <p:nvPr/>
+        </p:nvSpPr>
+        <p:spPr>
+          <a:xfrm>
+            <a:off x="932688" y="2258568"/>
+            <a:ext cx="393192" cy="329184"/>
+          </a:xfrm>
+          <a:prstGeom prst="rect">
+            <a:avLst/>
+          </a:prstGeom>
+          <a:noFill/>
+        </p:spPr>
+        <p:txBody>
+          <a:bodyPr wrap="square" anchor="ctr" lIns="18288" rIns="18288" tIns="18288" bIns="18288">
+            <a:spAutoFit/>
+          </a:bodyPr>
+          <a:lstStyle/>
+          <a:p>
+            <a:pPr algn="ctr">
+              <a:defRPr sz="900" b="1" i="0">
+                <a:solidFill>
+                  <a:srgbClr val="254638"/>
+                </a:solidFill>
+                <a:latin typeface="Aptos"/>
+              </a:defRPr>
+            </a:pPr>
+            <a:r>
+              <a:t>01</a:t>
+            </a:r>
+          </a:p>
+        </p:txBody>
+      </p:sp>
+      <p:sp>
+        <p:nvSpPr>
+          <p:cNvPr id="12" name="TextBox 11"/>
+          <p:cNvSpPr txBox="1"/>
+          <p:nvPr/>
+        </p:nvSpPr>
+        <p:spPr>
+          <a:xfrm>
+            <a:off x="1508760" y="2203703"/>
+            <a:ext cx="5440680" cy="237744"/>
+          </a:xfrm>
+          <a:prstGeom prst="rect">
+            <a:avLst/>
+          </a:prstGeom>
+          <a:noFill/>
+        </p:spPr>
+        <p:txBody>
+          <a:bodyPr wrap="square" anchor="ctr" lIns="18288" rIns="18288" tIns="18288" bIns="18288">
+            <a:spAutoFit/>
+          </a:bodyPr>
+          <a:lstStyle/>
+          <a:p>
+            <a:pPr algn="l">
+              <a:defRPr sz="1300" b="1" i="0">
+                <a:solidFill>
+                  <a:srgbClr val="242925"/>
+                </a:solidFill>
+                <a:latin typeface="Aptos"/>
+              </a:defRPr>
+            </a:pPr>
+            <a:r>
+              <a:t>Product Owner: Rafael Vicente</a:t>
+            </a:r>
+          </a:p>
+        </p:txBody>
+      </p:sp>
+      <p:sp>
+        <p:nvSpPr>
+          <p:cNvPr id="13" name="TextBox 12"/>
+          <p:cNvSpPr txBox="1"/>
+          <p:nvPr/>
+        </p:nvSpPr>
+        <p:spPr>
+          <a:xfrm>
+            <a:off x="1508760" y="2496312"/>
+            <a:ext cx="5440680" cy="228600"/>
+          </a:xfrm>
+          <a:prstGeom prst="rect">
+            <a:avLst/>
+          </a:prstGeom>
+          <a:noFill/>
+        </p:spPr>
+        <p:txBody>
+          <a:bodyPr wrap="square" anchor="ctr" lIns="18288" rIns="18288" tIns="18288" bIns="18288">
+            <a:spAutoFit/>
+          </a:bodyPr>
+          <a:lstStyle/>
+          <a:p>
+            <a:pPr algn="l">
+              <a:defRPr sz="1000" b="0" i="0">
+                <a:solidFill>
+                  <a:srgbClr val="6D746E"/>
+                </a:solidFill>
+                <a:latin typeface="Aptos"/>
+              </a:defRPr>
+            </a:pPr>
+            <a:r>
+              <a:t>Mantém a visão, ordena o backlog e aceita o incremento.</a:t>
+            </a:r>
+          </a:p>
+        </p:txBody>
+      </p:sp>
+      <p:sp>
+        <p:nvSpPr>
+          <p:cNvPr id="14" name="Rounded Rectangle 13"/>
+          <p:cNvSpPr/>
+          <p:nvPr/>
+        </p:nvSpPr>
+        <p:spPr>
+          <a:xfrm>
+            <a:off x="731520" y="3108960"/>
+            <a:ext cx="6766560" cy="777240"/>
+          </a:xfrm>
+          <a:prstGeom prst="roundRect">
+            <a:avLst>
+              <a:gd name="adj" fmla="val 12000"/>
+            </a:avLst>
+          </a:prstGeom>
+          <a:solidFill>
+            <a:srgbClr val="FFFFFF"/>
+          </a:solidFill>
+          <a:ln w="10160">
+            <a:solidFill>
+              <a:srgbClr val="DCDED8"/>
+            </a:solidFill>
+          </a:ln>
+        </p:spPr>
+        <p:style>
+          <a:lnRef idx="1">
+            <a:schemeClr val="accent1"/>
+          </a:lnRef>
+          <a:fillRef idx="3">
+            <a:schemeClr val="accent1"/>
+          </a:fillRef>
+          <a:effectRef idx="2">
+            <a:schemeClr val="accent1"/>
+          </a:effectRef>
+          <a:fontRef idx="minor">
+            <a:schemeClr val="lt1"/>
+          </a:fontRef>
+        </p:style>
+        <p:txBody>
+          <a:bodyPr rtlCol="0" anchor="ctr"/>
+          <a:lstStyle/>
+          <a:p>
+            <a:pPr algn="ctr"/>
+          </a:p>
+        </p:txBody>
+      </p:sp>
+      <p:sp>
+        <p:nvSpPr>
+          <p:cNvPr id="15" name="Rounded Rectangle 14"/>
+          <p:cNvSpPr/>
+          <p:nvPr/>
+        </p:nvSpPr>
+        <p:spPr>
+          <a:xfrm>
+            <a:off x="932688" y="3273552"/>
+            <a:ext cx="393192" cy="393192"/>
+          </a:xfrm>
+          <a:prstGeom prst="roundRect">
+            <a:avLst>
+              <a:gd name="adj" fmla="val 12000"/>
+            </a:avLst>
+          </a:prstGeom>
+          <a:solidFill>
+            <a:srgbClr val="DCE7DC"/>
+          </a:solidFill>
+          <a:ln w="10160">
+            <a:solidFill>
+              <a:srgbClr val="DCE7DC"/>
+            </a:solidFill>
+          </a:ln>
+        </p:spPr>
+        <p:style>
+          <a:lnRef idx="1">
+            <a:schemeClr val="accent1"/>
+          </a:lnRef>
+          <a:fillRef idx="3">
+            <a:schemeClr val="accent1"/>
+          </a:fillRef>
+          <a:effectRef idx="2">
+            <a:schemeClr val="accent1"/>
+          </a:effectRef>
+          <a:fontRef idx="minor">
+            <a:schemeClr val="lt1"/>
+          </a:fontRef>
+        </p:style>
+        <p:txBody>
+          <a:bodyPr rtlCol="0" anchor="ctr"/>
+          <a:lstStyle/>
+          <a:p>
+            <a:pPr algn="ctr"/>
+          </a:p>
+        </p:txBody>
+      </p:sp>
+      <p:sp>
+        <p:nvSpPr>
+          <p:cNvPr id="16" name="TextBox 15"/>
+          <p:cNvSpPr txBox="1"/>
+          <p:nvPr/>
+        </p:nvSpPr>
+        <p:spPr>
+          <a:xfrm>
+            <a:off x="932688" y="3282696"/>
+            <a:ext cx="393192" cy="329184"/>
+          </a:xfrm>
+          <a:prstGeom prst="rect">
+            <a:avLst/>
+          </a:prstGeom>
+          <a:noFill/>
+        </p:spPr>
+        <p:txBody>
+          <a:bodyPr wrap="square" anchor="ctr" lIns="18288" rIns="18288" tIns="18288" bIns="18288">
+            <a:spAutoFit/>
+          </a:bodyPr>
+          <a:lstStyle/>
+          <a:p>
+            <a:pPr algn="ctr">
+              <a:defRPr sz="900" b="1" i="0">
+                <a:solidFill>
+                  <a:srgbClr val="254638"/>
+                </a:solidFill>
+                <a:latin typeface="Aptos"/>
+              </a:defRPr>
+            </a:pPr>
+            <a:r>
+              <a:t>02</a:t>
+            </a:r>
+          </a:p>
+        </p:txBody>
+      </p:sp>
+      <p:sp>
+        <p:nvSpPr>
+          <p:cNvPr id="17" name="TextBox 16"/>
+          <p:cNvSpPr txBox="1"/>
+          <p:nvPr/>
+        </p:nvSpPr>
+        <p:spPr>
+          <a:xfrm>
+            <a:off x="1508760" y="3227832"/>
+            <a:ext cx="5440680" cy="237744"/>
+          </a:xfrm>
+          <a:prstGeom prst="rect">
+            <a:avLst/>
+          </a:prstGeom>
+          <a:noFill/>
+        </p:spPr>
+        <p:txBody>
+          <a:bodyPr wrap="square" anchor="ctr" lIns="18288" rIns="18288" tIns="18288" bIns="18288">
+            <a:spAutoFit/>
+          </a:bodyPr>
+          <a:lstStyle/>
+          <a:p>
+            <a:pPr algn="l">
+              <a:defRPr sz="1300" b="1" i="0">
+                <a:solidFill>
+                  <a:srgbClr val="242925"/>
+                </a:solidFill>
+                <a:latin typeface="Aptos"/>
+              </a:defRPr>
+            </a:pPr>
+            <a:r>
+              <a:t>Rotação alternada de PO</a:t>
+            </a:r>
+          </a:p>
+        </p:txBody>
+      </p:sp>
+      <p:sp>
+        <p:nvSpPr>
+          <p:cNvPr id="18" name="TextBox 17"/>
+          <p:cNvSpPr txBox="1"/>
+          <p:nvPr/>
+        </p:nvSpPr>
+        <p:spPr>
+          <a:xfrm>
+            <a:off x="1508760" y="3520440"/>
+            <a:ext cx="5440680" cy="228600"/>
+          </a:xfrm>
+          <a:prstGeom prst="rect">
+            <a:avLst/>
+          </a:prstGeom>
+          <a:noFill/>
+        </p:spPr>
+        <p:txBody>
+          <a:bodyPr wrap="square" anchor="ctr" lIns="18288" rIns="18288" tIns="18288" bIns="18288">
+            <a:spAutoFit/>
+          </a:bodyPr>
+          <a:lstStyle/>
+          <a:p>
+            <a:pPr algn="l">
+              <a:defRPr sz="1000" b="0" i="0">
+                <a:solidFill>
+                  <a:srgbClr val="6D746E"/>
+                </a:solidFill>
+                <a:latin typeface="Aptos"/>
+              </a:defRPr>
+            </a:pPr>
+            <a:r>
+              <a:t>S1 Rafael · S2 José · S3 Rafael · S4 José · S5 Rafael</a:t>
+            </a:r>
+          </a:p>
+        </p:txBody>
+      </p:sp>
+      <p:sp>
+        <p:nvSpPr>
+          <p:cNvPr id="19" name="Rounded Rectangle 18"/>
+          <p:cNvSpPr/>
+          <p:nvPr/>
+        </p:nvSpPr>
+        <p:spPr>
+          <a:xfrm>
+            <a:off x="731520" y="4133087"/>
+            <a:ext cx="6766560" cy="777240"/>
+          </a:xfrm>
+          <a:prstGeom prst="roundRect">
+            <a:avLst>
+              <a:gd name="adj" fmla="val 12000"/>
+            </a:avLst>
+          </a:prstGeom>
+          <a:solidFill>
+            <a:srgbClr val="FFFFFF"/>
+          </a:solidFill>
+          <a:ln w="10160">
+            <a:solidFill>
+              <a:srgbClr val="DCDED8"/>
+            </a:solidFill>
+          </a:ln>
+        </p:spPr>
+        <p:style>
+          <a:lnRef idx="1">
+            <a:schemeClr val="accent1"/>
+          </a:lnRef>
+          <a:fillRef idx="3">
+            <a:schemeClr val="accent1"/>
+          </a:fillRef>
+          <a:effectRef idx="2">
+            <a:schemeClr val="accent1"/>
+          </a:effectRef>
+          <a:fontRef idx="minor">
+            <a:schemeClr val="lt1"/>
+          </a:fontRef>
+        </p:style>
+        <p:txBody>
+          <a:bodyPr rtlCol="0" anchor="ctr"/>
+          <a:lstStyle/>
+          <a:p>
+            <a:pPr algn="ctr"/>
+          </a:p>
+        </p:txBody>
+      </p:sp>
+      <p:sp>
+        <p:nvSpPr>
+          <p:cNvPr id="20" name="Rounded Rectangle 19"/>
+          <p:cNvSpPr/>
+          <p:nvPr/>
+        </p:nvSpPr>
+        <p:spPr>
+          <a:xfrm>
+            <a:off x="932688" y="4297679"/>
+            <a:ext cx="393192" cy="393192"/>
+          </a:xfrm>
+          <a:prstGeom prst="roundRect">
+            <a:avLst>
+              <a:gd name="adj" fmla="val 12000"/>
+            </a:avLst>
+          </a:prstGeom>
+          <a:solidFill>
+            <a:srgbClr val="DCE7DC"/>
+          </a:solidFill>
+          <a:ln w="10160">
+            <a:solidFill>
+              <a:srgbClr val="DCE7DC"/>
+            </a:solidFill>
+          </a:ln>
+        </p:spPr>
+        <p:style>
+          <a:lnRef idx="1">
+            <a:schemeClr val="accent1"/>
+          </a:lnRef>
+          <a:fillRef idx="3">
+            <a:schemeClr val="accent1"/>
+          </a:fillRef>
+          <a:effectRef idx="2">
+            <a:schemeClr val="accent1"/>
+          </a:effectRef>
+          <a:fontRef idx="minor">
+            <a:schemeClr val="lt1"/>
+          </a:fontRef>
+        </p:style>
+        <p:txBody>
+          <a:bodyPr rtlCol="0" anchor="ctr"/>
+          <a:lstStyle/>
+          <a:p>
+            <a:pPr algn="ctr"/>
+          </a:p>
+        </p:txBody>
+      </p:sp>
+      <p:sp>
+        <p:nvSpPr>
+          <p:cNvPr id="21" name="TextBox 20"/>
+          <p:cNvSpPr txBox="1"/>
+          <p:nvPr/>
+        </p:nvSpPr>
+        <p:spPr>
+          <a:xfrm>
+            <a:off x="932688" y="4306824"/>
+            <a:ext cx="393192" cy="329184"/>
+          </a:xfrm>
+          <a:prstGeom prst="rect">
+            <a:avLst/>
+          </a:prstGeom>
+          <a:noFill/>
+        </p:spPr>
+        <p:txBody>
+          <a:bodyPr wrap="square" anchor="ctr" lIns="18288" rIns="18288" tIns="18288" bIns="18288">
+            <a:spAutoFit/>
+          </a:bodyPr>
+          <a:lstStyle/>
+          <a:p>
+            <a:pPr algn="ctr">
+              <a:defRPr sz="900" b="1" i="0">
+                <a:solidFill>
+                  <a:srgbClr val="254638"/>
+                </a:solidFill>
+                <a:latin typeface="Aptos"/>
+              </a:defRPr>
+            </a:pPr>
+            <a:r>
+              <a:t>03</a:t>
+            </a:r>
+          </a:p>
+        </p:txBody>
+      </p:sp>
+      <p:sp>
+        <p:nvSpPr>
+          <p:cNvPr id="22" name="TextBox 21"/>
+          <p:cNvSpPr txBox="1"/>
+          <p:nvPr/>
+        </p:nvSpPr>
+        <p:spPr>
+          <a:xfrm>
+            <a:off x="1508760" y="4251959"/>
+            <a:ext cx="5440680" cy="237744"/>
+          </a:xfrm>
+          <a:prstGeom prst="rect">
+            <a:avLst/>
+          </a:prstGeom>
+          <a:noFill/>
+        </p:spPr>
+        <p:txBody>
+          <a:bodyPr wrap="square" anchor="ctr" lIns="18288" rIns="18288" tIns="18288" bIns="18288">
+            <a:spAutoFit/>
+          </a:bodyPr>
+          <a:lstStyle/>
+          <a:p>
+            <a:pPr algn="l">
+              <a:defRPr sz="1300" b="1" i="0">
+                <a:solidFill>
+                  <a:srgbClr val="242925"/>
+                </a:solidFill>
+                <a:latin typeface="Aptos"/>
+              </a:defRPr>
+            </a:pPr>
+            <a:r>
+              <a:t>Contrato de equipa</a:t>
+            </a:r>
+          </a:p>
+        </p:txBody>
+      </p:sp>
+      <p:sp>
+        <p:nvSpPr>
+          <p:cNvPr id="23" name="TextBox 22"/>
+          <p:cNvSpPr txBox="1"/>
+          <p:nvPr/>
+        </p:nvSpPr>
+        <p:spPr>
+          <a:xfrm>
+            <a:off x="1508760" y="4544568"/>
+            <a:ext cx="5440680" cy="228600"/>
+          </a:xfrm>
+          <a:prstGeom prst="rect">
+            <a:avLst/>
+          </a:prstGeom>
+          <a:noFill/>
+        </p:spPr>
+        <p:txBody>
+          <a:bodyPr wrap="square" anchor="ctr" lIns="18288" rIns="18288" tIns="18288" bIns="18288">
+            <a:spAutoFit/>
+          </a:bodyPr>
+          <a:lstStyle/>
+          <a:p>
+            <a:pPr algn="l">
+              <a:defRPr sz="1000" b="0" i="0">
+                <a:solidFill>
+                  <a:srgbClr val="6D746E"/>
+                </a:solidFill>
+                <a:latin typeface="Aptos"/>
+              </a:defRPr>
+            </a:pPr>
+            <a:r>
+              <a:t>Assinado pelos dois a 15/10/2026.</a:t>
+            </a:r>
+          </a:p>
+        </p:txBody>
+      </p:sp>
+      <p:sp>
+        <p:nvSpPr>
+          <p:cNvPr id="24" name="Rounded Rectangle 23"/>
+          <p:cNvSpPr/>
+          <p:nvPr/>
+        </p:nvSpPr>
+        <p:spPr>
+          <a:xfrm>
+            <a:off x="7909560" y="2084831"/>
+            <a:ext cx="3493008" cy="2825496"/>
+          </a:xfrm>
+          <a:prstGeom prst="roundRect">
+            <a:avLst>
+              <a:gd name="adj" fmla="val 12000"/>
+            </a:avLst>
+          </a:prstGeom>
+          <a:solidFill>
+            <a:srgbClr val="254638"/>
+          </a:solidFill>
+          <a:ln w="10160">
+            <a:solidFill>
+              <a:srgbClr val="254638"/>
+            </a:solidFill>
+          </a:ln>
+        </p:spPr>
+        <p:style>
+          <a:lnRef idx="1">
+            <a:schemeClr val="accent1"/>
+          </a:lnRef>
+          <a:fillRef idx="3">
+            <a:schemeClr val="accent1"/>
+          </a:fillRef>
+          <a:effectRef idx="2">
+            <a:schemeClr val="accent1"/>
+          </a:effectRef>
+          <a:fontRef idx="minor">
+            <a:schemeClr val="lt1"/>
+          </a:fontRef>
+        </p:style>
+        <p:txBody>
+          <a:bodyPr rtlCol="0" anchor="ctr"/>
+          <a:lstStyle/>
+          <a:p>
+            <a:pPr algn="ctr"/>
+          </a:p>
+        </p:txBody>
+      </p:sp>
+      <p:sp>
+        <p:nvSpPr>
+          <p:cNvPr id="25" name="TextBox 24"/>
+          <p:cNvSpPr txBox="1"/>
+          <p:nvPr/>
+        </p:nvSpPr>
+        <p:spPr>
+          <a:xfrm>
+            <a:off x="8211312" y="2359152"/>
+            <a:ext cx="2871216" cy="274320"/>
+          </a:xfrm>
+          <a:prstGeom prst="rect">
+            <a:avLst/>
+          </a:prstGeom>
+          <a:noFill/>
+        </p:spPr>
+        <p:txBody>
+          <a:bodyPr wrap="square" anchor="ctr" lIns="18288" rIns="18288" tIns="18288" bIns="18288">
+            <a:spAutoFit/>
+          </a:bodyPr>
+          <a:lstStyle/>
+          <a:p>
+            <a:pPr algn="l">
+              <a:defRPr sz="900" b="1" i="0">
+                <a:solidFill>
+                  <a:srgbClr val="DCE7DC"/>
+                </a:solidFill>
+                <a:latin typeface="Aptos"/>
+              </a:defRPr>
+            </a:pPr>
+            <a:r>
+              <a:t>JIRA · SPRINT 1</a:t>
+            </a:r>
+          </a:p>
+        </p:txBody>
+      </p:sp>
+      <p:sp>
+        <p:nvSpPr>
+          <p:cNvPr id="26" name="TextBox 25"/>
+          <p:cNvSpPr txBox="1"/>
+          <p:nvPr/>
+        </p:nvSpPr>
+        <p:spPr>
+          <a:xfrm>
+            <a:off x="8211312" y="2798064"/>
+            <a:ext cx="2871216" cy="841248"/>
+          </a:xfrm>
+          <a:prstGeom prst="rect">
+            <a:avLst/>
+          </a:prstGeom>
+          <a:noFill/>
+        </p:spPr>
+        <p:txBody>
+          <a:bodyPr wrap="square" anchor="ctr" lIns="18288" rIns="18288" tIns="18288" bIns="18288">
+            <a:spAutoFit/>
+          </a:bodyPr>
+          <a:lstStyle/>
+          <a:p>
+            <a:pPr algn="l">
+              <a:defRPr sz="4200" b="1" i="0">
+                <a:solidFill>
+                  <a:srgbClr val="FFFFFF"/>
+                </a:solidFill>
+                <a:latin typeface="Aptos"/>
+              </a:defRPr>
+            </a:pPr>
+            <a:r>
+              <a:t>5 / 5</a:t>
+            </a:r>
+          </a:p>
+        </p:txBody>
+      </p:sp>
+      <p:sp>
+        <p:nvSpPr>
+          <p:cNvPr id="27" name="TextBox 26"/>
+          <p:cNvSpPr txBox="1"/>
+          <p:nvPr/>
+        </p:nvSpPr>
+        <p:spPr>
+          <a:xfrm>
+            <a:off x="8247888" y="3776472"/>
+            <a:ext cx="2743200" cy="347472"/>
+          </a:xfrm>
+          <a:prstGeom prst="rect">
+            <a:avLst/>
+          </a:prstGeom>
+          <a:noFill/>
+        </p:spPr>
+        <p:txBody>
+          <a:bodyPr wrap="square" anchor="ctr" lIns="18288" rIns="18288" tIns="18288" bIns="18288">
+            <a:spAutoFit/>
+          </a:bodyPr>
+          <a:lstStyle/>
+          <a:p>
+            <a:pPr algn="l">
+              <a:defRPr sz="1400" b="0" i="0">
+                <a:solidFill>
+                  <a:srgbClr val="FFFFFF"/>
+                </a:solidFill>
+                <a:latin typeface="Aptos"/>
+              </a:defRPr>
+            </a:pPr>
+            <a:r>
+              <a:t>issues concluídas</a:t>
+            </a:r>
+          </a:p>
+        </p:txBody>
+      </p:sp>
+      <p:sp>
+        <p:nvSpPr>
+          <p:cNvPr id="28" name="Rounded Rectangle 27"/>
+          <p:cNvSpPr/>
+          <p:nvPr/>
+        </p:nvSpPr>
+        <p:spPr>
+          <a:xfrm>
+            <a:off x="8229600" y="4334256"/>
+            <a:ext cx="1353312" cy="292608"/>
+          </a:xfrm>
+          <a:prstGeom prst="roundRect">
+            <a:avLst>
+              <a:gd name="adj" fmla="val 12000"/>
+            </a:avLst>
+          </a:prstGeom>
+          <a:solidFill>
+            <a:srgbClr val="DCE7DC"/>
+          </a:solidFill>
+          <a:ln w="10160">
+            <a:solidFill>
+              <a:srgbClr val="DCE7DC"/>
+            </a:solidFill>
+          </a:ln>
+        </p:spPr>
+        <p:style>
+          <a:lnRef idx="1">
+            <a:schemeClr val="accent1"/>
+          </a:lnRef>
+          <a:fillRef idx="3">
+            <a:schemeClr val="accent1"/>
+          </a:fillRef>
+          <a:effectRef idx="2">
+            <a:schemeClr val="accent1"/>
+          </a:effectRef>
+          <a:fontRef idx="minor">
+            <a:schemeClr val="lt1"/>
+          </a:fontRef>
+        </p:style>
+        <p:txBody>
+          <a:bodyPr rtlCol="0" anchor="ctr"/>
+          <a:lstStyle/>
+          <a:p>
+            <a:pPr algn="ctr"/>
+          </a:p>
+        </p:txBody>
+      </p:sp>
+      <p:sp>
+        <p:nvSpPr>
+          <p:cNvPr id="29" name="TextBox 28"/>
+          <p:cNvSpPr txBox="1"/>
+          <p:nvPr/>
+        </p:nvSpPr>
+        <p:spPr>
+          <a:xfrm>
+            <a:off x="8293608" y="4347972"/>
+            <a:ext cx="1225295" cy="246888"/>
+          </a:xfrm>
+          <a:prstGeom prst="rect">
+            <a:avLst/>
+          </a:prstGeom>
+          <a:noFill/>
+        </p:spPr>
+        <p:txBody>
+          <a:bodyPr wrap="square" anchor="ctr" lIns="18288" rIns="18288" tIns="18288" bIns="18288">
+            <a:spAutoFit/>
+          </a:bodyPr>
+          <a:lstStyle/>
+          <a:p>
+            <a:pPr algn="ctr">
+              <a:defRPr sz="900" b="1" i="0">
+                <a:solidFill>
+                  <a:srgbClr val="254638"/>
+                </a:solidFill>
+                <a:latin typeface="Aptos"/>
+              </a:defRPr>
+            </a:pPr>
+            <a:r>
+              <a:t>XOG board</a:t>
+            </a:r>
+          </a:p>
+        </p:txBody>
+      </p:sp>
+      <p:sp>
+        <p:nvSpPr>
+          <p:cNvPr id="30" name="TextBox 29"/>
+          <p:cNvSpPr txBox="1"/>
+          <p:nvPr/>
+        </p:nvSpPr>
+        <p:spPr>
+          <a:xfrm>
+            <a:off x="758952" y="5468112"/>
+            <a:ext cx="10424160" cy="384048"/>
+          </a:xfrm>
+          <a:prstGeom prst="rect">
+            <a:avLst/>
+          </a:prstGeom>
+          <a:noFill/>
+        </p:spPr>
+        <p:txBody>
+          <a:bodyPr wrap="square" anchor="ctr" lIns="18288" rIns="18288" tIns="18288" bIns="18288">
+            <a:spAutoFit/>
+          </a:bodyPr>
+          <a:lstStyle/>
+          <a:p>
+            <a:pPr algn="l">
+              <a:defRPr sz="1200" b="0" i="1">
+                <a:solidFill>
+                  <a:srgbClr val="6D746E"/>
+                </a:solidFill>
+                <a:latin typeface="Aptos"/>
+              </a:defRPr>
+            </a:pPr>
+            <a:r>
+              <a:t>Review e retrospetiva registadas no Jira. Ação para o Sprint 2: push diário com CI a passar.</a:t>
             </a:r>
           </a:p>
         </p:txBody>

</xml_diff>